<commit_message>
docs: fix presentation - remove italic text (hard to read in Cyrillic), clarify Travel Planner is the student's own app not a pre-existing one
</commit_message>
<xml_diff>
--- a/docs/prezentacija-odbrana.pptx
+++ b/docs/prezentacija-odbrana.pptx
@@ -3631,7 +3631,7 @@
               </a:lnSpc>
             </a:pPr>
             <a:r>
-              <a:rPr sz="1400" b="0" i="1">
+              <a:rPr sz="1400" b="0" i="0">
                 <a:solidFill>
                   <a:srgbClr val="5A6370"/>
                 </a:solidFill>
@@ -5167,7 +5167,7 @@
               </a:lnSpc>
             </a:pPr>
             <a:r>
-              <a:rPr sz="1350" b="0" i="1">
+              <a:rPr sz="1350" b="0" i="0">
                 <a:solidFill>
                   <a:srgbClr val="5A6370"/>
                 </a:solidFill>
@@ -6036,7 +6036,7 @@
                 </a:solidFill>
                 <a:latin typeface="Calibri"/>
               </a:rPr>
-              <a:t>Travel Planner — постојећа апликација</a:t>
+              <a:t>Travel Planner — апликација коју сам развила</a:t>
             </a:r>
           </a:p>
         </p:txBody>
@@ -6508,7 +6508,7 @@
               </a:lnSpc>
             </a:pPr>
             <a:r>
-              <a:rPr sz="1900" b="0" i="1">
+              <a:rPr sz="1900" b="0" i="0">
                 <a:solidFill>
                   <a:srgbClr val="1A1F2B"/>
                 </a:solidFill>
@@ -6654,7 +6654,7 @@
               </a:lnSpc>
             </a:pPr>
             <a:r>
-              <a:rPr sz="1500" b="0" i="1">
+              <a:rPr sz="1500" b="0" i="0">
                 <a:solidFill>
                   <a:srgbClr val="5A6370"/>
                 </a:solidFill>
@@ -8051,7 +8051,7 @@
               </a:lnSpc>
             </a:pPr>
             <a:r>
-              <a:rPr sz="1700" b="0" i="1">
+              <a:rPr sz="1700" b="0" i="0">
                 <a:solidFill>
                   <a:srgbClr val="5A6370"/>
                 </a:solidFill>

</xml_diff>